<commit_message>
Recheck Semester 1 Week 4: lecture wording, references and correlation notes
- 1 Lecture: "Next" on slide 30 now points to Week 5 (regression); slide 7
  "Itemset:"; reference fixes (Agarwal et al. 2001, "Beyond market baskets");
  typo fixes on slides 4, 11, 20, 25 and 33; title added to slide 29.
- 01 Market Basket: punctuation in section 6, leftover "In all seriousness" reworded.
- 02 Correlation: zero correlation explained correctly, Pearson and Spearman
  formulas on one line each, scatter plot output from the current kernel.
- 03 Exercise: stub wording covers Exercise 4 (pass); Solution: typo.

Co-Authored-By: Claude Opus 5.5 <noreply@anthropic.com>
Claude-Session: https://claude.ai/code/session_01VxynPNj67CswVjMFBfhw8j

[skip ci]
</commit_message>
<xml_diff>
--- a/content/Lectures/Semester 1/Week 4/1 Lecture/1.4 Mining Frequent Patterns (Lecture).pptx
+++ b/content/Lectures/Semester 1/Week 4/1 Lecture/1.4 Mining Frequent Patterns (Lecture).pptx
@@ -4215,7 +4215,7 @@
           <a:p>
             <a:r>
               <a:rPr lang="en-GB" sz="1800" dirty="0"/>
-              <a:t>We call any proper subset of a pattern, a sub-pattern. Here is an example,</a:t>
+              <a:t>We call any proper subset of a pattern, a sub-pattern. Here is an example:</a:t>
             </a:r>
           </a:p>
           <a:p>
@@ -4229,7 +4229,7 @@
             </a:r>
             <a:r>
               <a:rPr lang="en-GB" sz="1800" dirty="0"/>
-              <a:t>, are all sub patterns.</a:t>
+              <a:t>, are all sub-patterns.</a:t>
             </a:r>
           </a:p>
           <a:p>
@@ -4268,7 +4268,7 @@
           <a:p>
             <a:r>
               <a:rPr lang="en-GB" sz="1800" dirty="0"/>
-              <a:t>A super pattern of a pattern is a proper super set of the pattern. </a:t>
+              <a:t>A super pattern of a pattern is a proper superset of the pattern. </a:t>
             </a:r>
           </a:p>
           <a:p>
@@ -6369,7 +6369,7 @@
             </a:r>
             <a:r>
               <a:rPr lang="en-US" altLang="en-US" sz="2000" dirty="0"/>
-              <a:t>, et al. @ KDD’ 94)</a:t>
+              <a:t>, et al. @ KDD’94)</a:t>
             </a:r>
           </a:p>
           <a:p>
@@ -7439,7 +7439,7 @@
           <a:p>
             <a:r>
               <a:rPr lang="en-US" altLang="en-US" sz="2000" dirty="0"/>
-              <a:t>J. Park, M. Chen, and P. Yu. </a:t>
+              <a:t>J. S. Park, M. S. Chen, and P. S. Yu. </a:t>
             </a:r>
             <a:r>
               <a:rPr lang="en-US" altLang="en-US" sz="2000" dirty="0">
@@ -10408,7 +10408,11 @@
           <a:bodyPr/>
           <a:lstStyle/>
           <a:p>
-            <a:endParaRPr lang="en-GB"/>
+            <a:r>
+              <a:rPr lang="en-US" altLang="en-US" sz="2800" dirty="0"/>
+              <a:t>ECLAT Example: Horizontal vs Vertical Data Layout</a:t>
+            </a:r>
+            <a:endParaRPr lang="en-GB" sz="2800" dirty="0"/>
           </a:p>
         </p:txBody>
       </p:sp>
@@ -10454,8 +10458,8 @@
         </p:blipFill>
         <p:spPr bwMode="auto">
           <a:xfrm>
-            <a:off x="1905000" y="228600"/>
-            <a:ext cx="6477000" cy="6397601"/>
+            <a:off x="2425071" y="1350000"/>
+            <a:ext cx="5475100" cy="5408000"/>
           </a:xfrm>
           <a:prstGeom prst="rect">
             <a:avLst/>
@@ -10854,7 +10858,7 @@
             </a:pPr>
             <a:r>
               <a:rPr lang="en-GB" sz="2000" dirty="0"/>
-              <a:t>Lecture: Decision Tree (Classification problem)</a:t>
+              <a:t>Lecture: Regression Problems</a:t>
             </a:r>
           </a:p>
           <a:p>
@@ -10866,7 +10870,7 @@
             </a:pPr>
             <a:r>
               <a:rPr lang="en-GB" sz="2000" dirty="0"/>
-              <a:t>Practical: Decision Tree with Python</a:t>
+              <a:t>Practical: Exploring Machine Learning with Python</a:t>
             </a:r>
             <a:endParaRPr lang="en-US" sz="2000" dirty="0"/>
           </a:p>
@@ -12114,7 +12118,7 @@
                 <a:latin typeface="Calibri" pitchFamily="34" charset="0"/>
                 <a:cs typeface="Calibri" pitchFamily="34" charset="0"/>
               </a:rPr>
-              <a:t>. J. Parallel and Distributed Computing, 2002.</a:t>
+              <a:t>. J. Parallel and Distributed Computing, 2001.</a:t>
             </a:r>
           </a:p>
           <a:p>
@@ -12226,7 +12230,7 @@
                 <a:latin typeface="Calibri" pitchFamily="34" charset="0"/>
                 <a:cs typeface="Calibri" pitchFamily="34" charset="0"/>
               </a:rPr>
-              <a:t>  SIGMOD’ 00</a:t>
+              <a:t>  SIGMOD’00</a:t>
             </a:r>
           </a:p>
           <a:p>
@@ -13026,7 +13030,7 @@
                 <a:latin typeface="Calibri" pitchFamily="34" charset="0"/>
                 <a:cs typeface="Calibri" pitchFamily="34" charset="0"/>
               </a:rPr>
-              <a:t>, and C. Silverstein.   Beyond market basket: Generalizing association rules to correlations.  SIGMOD'97.</a:t>
+              <a:t>, and C. Silverstein.   Beyond market baskets: Generalizing association rules to correlations.  SIGMOD'97.</a:t>
             </a:r>
           </a:p>
           <a:p>
@@ -13483,7 +13487,7 @@
           <a:p>
             <a:r>
               <a:rPr lang="en-GB" dirty="0"/>
-              <a:t>How do we identify these frequent patterns from dataset (big)?</a:t>
+              <a:t>How do we identify these frequent patterns from a (big) dataset?</a:t>
             </a:r>
           </a:p>
           <a:p>
@@ -14708,7 +14712,7 @@
                   <a:schemeClr val="hlink"/>
                 </a:solidFill>
               </a:rPr>
-              <a:t>Itemset(Dataset)</a:t>
+              <a:t>Itemset</a:t>
             </a:r>
             <a:r>
               <a:rPr lang="en-US" altLang="en-US" sz="1600" dirty="0"/>

</xml_diff>